<commit_message>
make new changes according to ananya file
</commit_message>
<xml_diff>
--- a/MTG2A01_L04_S01_build_v2_review.pptx
+++ b/MTG2A01_L04_S01_build_v2_review.pptx
@@ -3849,7 +3849,7 @@
                   <a:srgbClr val="1B2A44"/>
                 </a:solidFill>
               </a:rPr>
-              <a:t>• Landing (deck p1): title 'संख्याओं का घटाव', equation 20 − 10 = ?, greeting VO. Shell (room card, play button, Swiftie) is MTG2A01_L03_S01's.</a:t>
+              <a:t>• Landing (deck p1): title 'संख्याओं का घटाव', the deck's 20 − 10 = ? (a small pill), and the sibling's castle scene: Aman (boy) and Meera (girl) zip in and finish the toy-block castle; greeting VO.</a:t>
             </a:r>
           </a:p>
         </p:txBody>
@@ -3967,7 +3967,7 @@
                   <a:srgbClr val="1B2A44"/>
                 </a:solidFill>
               </a:rPr>
-              <a:t>• T1 (deck p2): 'कितने बचे?' — 25, then − 13, then = ? appear as the Meera/Aman VO names them. The dangling 'मीरा के पास' at the end of the deck's first line is dropped.</a:t>
+              <a:t>• T1 (deck p2): 'कितने बचे?' — Meera (girl) with her 25 blocks; on 'उनमें से तेरह ब्लॉक्स मीरा ने अमन को दिए हैं।' 1 rod + 3 cubes fly to Aman (boy); 25, − 13, = ? appear with the VO (the sibling's story page).</a:t>
             </a:r>
           </a:p>
         </p:txBody>
@@ -4321,7 +4321,7 @@
                   <a:srgbClr val="1B2A44"/>
                 </a:solidFill>
               </a:rPr>
-              <a:t>• T3: the first screen again; the 12 lands in the box on '12 आएगा', then 'यानी मीरा के पास कुल 12 ब्लॉक्स बचे।'</a:t>
+              <a:t>• T3: the same page; '…तो बचे 12।' lights Meera's blocks, on '12 आएगा' a copy of them moves into the third column and the ? becomes 12.</a:t>
             </a:r>
           </a:p>
         </p:txBody>

</xml_diff>

<commit_message>
made changes suggested by saifur
</commit_message>
<xml_diff>
--- a/MTG2A01_L04_S01_build_v2_review.pptx
+++ b/MTG2A01_L04_S01_build_v2_review.pptx
@@ -18,7 +18,6 @@
     <p:sldId id="266" r:id="rId17"/>
     <p:sldId id="267" r:id="rId18"/>
     <p:sldId id="268" r:id="rId19"/>
-    <p:sldId id="269" r:id="rId20"/>
   </p:sldIdLst>
   <p:sldSz cx="12191695" cy="6858000" type="screen4x3"/>
   <p:notesSz cx="6858000" cy="9144000"/>
@@ -3130,7 +3129,7 @@
                   <a:srgbClr val="0B3D8C"/>
                 </a:solidFill>
               </a:rPr>
-              <a:t>MTG2A01_L04_S01 — संख्याओं का घटाव · build v2 (review 2 applied)</a:t>
+              <a:t>MTG2A01_L04_S01 — संख्याओं का घटाव · build v2</a:t>
             </a:r>
           </a:p>
           <a:p>
@@ -3141,7 +3140,7 @@
                   <a:srgbClr val="5A6678"/>
                 </a:solidFill>
               </a:rPr>
-              <a:t>Page-by-page review · 13 pages</a:t>
+              <a:t>Page-by-page review · 12 pages</a:t>
             </a:r>
           </a:p>
         </p:txBody>
@@ -3192,14 +3191,14 @@
                   <a:srgbClr val="0B3D8C"/>
                 </a:solidFill>
               </a:rPr>
-              <a:t>Page 9 · 09_P1_79-34.png</a:t>
+              <a:t>Page 9 · 10_P2_86-56.png</a:t>
             </a:r>
           </a:p>
         </p:txBody>
       </p:sp>
       <p:pic>
         <p:nvPicPr>
-          <p:cNvPr id="3" name="Picture 2" descr="09_P1_79-34.png"/>
+          <p:cNvPr id="3" name="Picture 2" descr="10_P2_86-56.png"/>
           <p:cNvPicPr>
             <a:picLocks noChangeAspect="1"/>
           </p:cNvPicPr>
@@ -3259,7 +3258,7 @@
                   <a:srgbClr val="1B2A44"/>
                 </a:solidFill>
               </a:rPr>
-              <a:t>• P1 (deck p9): 79 − 34 → number pad. Shown: the right answer after the reveal (keys 4 then 5 lit one by one, the others locked).</a:t>
+              <a:t>• P2: practice - the tens stay locked (dimmed) until the 6 ones are taken; heads count what is left; 3rd wrong: digits 3 / 0 under the blocks + reveal.</a:t>
             </a:r>
           </a:p>
         </p:txBody>
@@ -3310,14 +3309,14 @@
                   <a:srgbClr val="0B3D8C"/>
                 </a:solidFill>
               </a:rPr>
-              <a:t>Page 10 · 10_P2_86-56.png</a:t>
+              <a:t>Page 10 · 11_P3_45-12.png</a:t>
             </a:r>
           </a:p>
         </p:txBody>
       </p:sp>
       <p:pic>
         <p:nvPicPr>
-          <p:cNvPr id="3" name="Picture 2" descr="10_P2_86-56.png"/>
+          <p:cNvPr id="3" name="Picture 2" descr="11_P3_45-12.png"/>
           <p:cNvPicPr>
             <a:picLocks noChangeAspect="1"/>
           </p:cNvPicPr>
@@ -3377,7 +3376,7 @@
                   <a:srgbClr val="1B2A44"/>
                 </a:solidFill>
               </a:rPr>
-              <a:t>• P2 (deck p11): 86 − 56 given as blocks, no step VO; heads follow what is left (3 दहाई / 0 इकाई); options 30 / 40 / 13.</a:t>
+              <a:t>• P3 (no blocks): wrong 1 'संख्याओं में से पहले इकाई घटाइए, फिर दहाई घटाइए।' (ones digits, then tens digits light); 2 the 45 blocks come in and 12 are taken away, the table stays (heads count 3 / 3) + recount line; 3 digits under the blocks + reveal.</a:t>
             </a:r>
           </a:p>
         </p:txBody>
@@ -3428,14 +3427,14 @@
                   <a:srgbClr val="0B3D8C"/>
                 </a:solidFill>
               </a:rPr>
-              <a:t>Page 11 · 11_P3_45-12.png</a:t>
+              <a:t>Page 11 · 12_P4_90-40.png</a:t>
             </a:r>
           </a:p>
         </p:txBody>
       </p:sp>
       <p:pic>
         <p:nvPicPr>
-          <p:cNvPr id="3" name="Picture 2" descr="11_P3_45-12.png"/>
+          <p:cNvPr id="3" name="Picture 2" descr="12_P4_90-40.png"/>
           <p:cNvPicPr>
             <a:picLocks noChangeAspect="1"/>
           </p:cNvPicPr>
@@ -3495,7 +3494,7 @@
                   <a:srgbClr val="1B2A44"/>
                 </a:solidFill>
               </a:rPr>
-              <a:t>• P3 (deck p13): only 45 − 12 = ? and 57 / 23 / 33; 'फिर से घटाइए।' → reveal.</a:t>
+              <a:t>• P4 (no blocks): the same ladder with the number pad - after the blocks, digits 5 / 0 under them and the keys 5, 0, ✓ light in turn.</a:t>
             </a:r>
           </a:p>
         </p:txBody>
@@ -3546,125 +3545,7 @@
                   <a:srgbClr val="0B3D8C"/>
                 </a:solidFill>
               </a:rPr>
-              <a:t>Page 12 · 12_P4_90-40.png</a:t>
-            </a:r>
-          </a:p>
-        </p:txBody>
-      </p:sp>
-      <p:pic>
-        <p:nvPicPr>
-          <p:cNvPr id="3" name="Picture 2" descr="12_P4_90-40.png"/>
-          <p:cNvPicPr>
-            <a:picLocks noChangeAspect="1"/>
-          </p:cNvPicPr>
-          <p:nvPr/>
-        </p:nvPicPr>
-        <p:blipFill>
-          <a:blip r:embed="rId2"/>
-          <a:stretch>
-            <a:fillRect/>
-          </a:stretch>
-        </p:blipFill>
-        <p:spPr>
-          <a:xfrm>
-            <a:off x="365760" y="731520"/>
-            <a:ext cx="7680960" cy="3492938"/>
-          </a:xfrm>
-          <a:prstGeom prst="rect">
-            <a:avLst/>
-          </a:prstGeom>
-        </p:spPr>
-      </p:pic>
-      <p:sp>
-        <p:nvSpPr>
-          <p:cNvPr id="4" name="TextBox 3"/>
-          <p:cNvSpPr txBox="1"/>
-          <p:nvPr/>
-        </p:nvSpPr>
-        <p:spPr>
-          <a:xfrm>
-            <a:off x="8229600" y="731520"/>
-            <a:ext cx="3596335" cy="5760720"/>
-          </a:xfrm>
-          <a:prstGeom prst="rect">
-            <a:avLst/>
-          </a:prstGeom>
-          <a:noFill/>
-        </p:spPr>
-        <p:txBody>
-          <a:bodyPr wrap="square">
-            <a:spAutoFit/>
-          </a:bodyPr>
-          <a:lstStyle/>
-          <a:p>
-            <a:r>
-              <a:rPr sz="1600" b="1">
-                <a:solidFill>
-                  <a:srgbClr val="0B3D8C"/>
-                </a:solidFill>
-              </a:rPr>
-              <a:t>Recommendations</a:t>
-            </a:r>
-          </a:p>
-          <a:p>
-            <a:r>
-              <a:rPr sz="1300">
-                <a:solidFill>
-                  <a:srgbClr val="1B2A44"/>
-                </a:solidFill>
-              </a:rPr>
-              <a:t>• P4 (deck p15): 90 − 40 (deck text said 96 − 40 / 55; mockup + correct VO + keys say 90 − 40 = 50); try again → place-value hint (ones digits, then tens digits light) → reveal.</a:t>
-            </a:r>
-          </a:p>
-        </p:txBody>
-      </p:sp>
-    </p:spTree>
-  </p:cSld>
-  <p:clrMapOvr>
-    <a:masterClrMapping/>
-  </p:clrMapOvr>
-</p:sld>
-</file>
-
-<file path=ppt/slides/slide14.xml><?xml version="1.0" encoding="utf-8"?>
-<p:sld xmlns:a="http://schemas.openxmlformats.org/drawingml/2006/main" xmlns:p="http://schemas.openxmlformats.org/presentationml/2006/main" xmlns:r="http://schemas.openxmlformats.org/officeDocument/2006/relationships">
-  <p:cSld>
-    <p:spTree>
-      <p:nvGrpSpPr>
-        <p:cNvPr id="1" name=""/>
-        <p:cNvGrpSpPr/>
-        <p:nvPr/>
-      </p:nvGrpSpPr>
-      <p:grpSpPr/>
-      <p:sp>
-        <p:nvSpPr>
-          <p:cNvPr id="2" name="TextBox 1"/>
-          <p:cNvSpPr txBox="1"/>
-          <p:nvPr/>
-        </p:nvSpPr>
-        <p:spPr>
-          <a:xfrm>
-            <a:off x="365760" y="137160"/>
-            <a:ext cx="7680960" cy="548640"/>
-          </a:xfrm>
-          <a:prstGeom prst="rect">
-            <a:avLst/>
-          </a:prstGeom>
-          <a:noFill/>
-        </p:spPr>
-        <p:txBody>
-          <a:bodyPr wrap="none">
-            <a:spAutoFit/>
-          </a:bodyPr>
-          <a:lstStyle/>
-          <a:p>
-            <a:r>
-              <a:rPr sz="1400" b="1">
-                <a:solidFill>
-                  <a:srgbClr val="0B3D8C"/>
-                </a:solidFill>
-              </a:rPr>
-              <a:t>Page 13 · 13_CEL.png</a:t>
+              <a:t>Page 12 · 13_CEL.png</a:t>
             </a:r>
           </a:p>
         </p:txBody>
@@ -4203,7 +4084,7 @@
                   <a:srgbClr val="1B2A44"/>
                 </a:solidFill>
               </a:rPr>
-              <a:t>• T2 take-away: 25 − 13; Swiftee takes 3 ones (grey copies stay, a copy flies to 13), 2 move to the answer table ('2 इकाई'); the CHILD takes 1 ten (3 s idle → hand), then '…यानी 12' and 12 fills the box. VO fixed: 13 = 1 दहाई और 3 इकाई (deck said 2).</a:t>
+              <a:t>• T2 (deck p3, with page 3 folded in): after the take-away the left table goes and the answer table takes the middle, '= 12' beside it; then 'यहाँ हमने पच्चीस में से तेरह घटाए हैं…', the 12 lands in the ? on '12 आएगा', 'यानी मीरा के पास कुल 12 ब्लॉक्स बचे।'</a:t>
             </a:r>
           </a:p>
         </p:txBody>
@@ -4254,14 +4135,14 @@
                   <a:srgbClr val="0B3D8C"/>
                 </a:solidFill>
               </a:rPr>
-              <a:t>Page 5 · 05_T3_answer.png</a:t>
+              <a:t>Page 5 · 06_G1_34-21.png</a:t>
             </a:r>
           </a:p>
         </p:txBody>
       </p:sp>
       <p:pic>
         <p:nvPicPr>
-          <p:cNvPr id="3" name="Picture 2" descr="05_T3_answer.png"/>
+          <p:cNvPr id="3" name="Picture 2" descr="06_G1_34-21.png"/>
           <p:cNvPicPr>
             <a:picLocks noChangeAspect="1"/>
           </p:cNvPicPr>
@@ -4321,7 +4202,7 @@
                   <a:srgbClr val="1B2A44"/>
                 </a:solidFill>
               </a:rPr>
-              <a:t>• T3: the same page; '…तो बचे 12।' lights Meera's blocks, on '12 आएगा' a copy of them moves into the third column and the ? becomes 12.</a:t>
+              <a:t>• G1 (deck p7): 34 − 21 — child builds with −/+, takes away (ladder: 1st wrong = column line, 2nd = 'इनमें से इतने हटाइए।' + only the needed blocks tappable), the left blocks move right, 13 fills the box, 'इसलिए 34 घटा 21 बराबर 13' in sync.</a:t>
             </a:r>
           </a:p>
         </p:txBody>
@@ -4372,14 +4253,14 @@
                   <a:srgbClr val="0B3D8C"/>
                 </a:solidFill>
               </a:rPr>
-              <a:t>Page 6 · 06_G1_34-21.png</a:t>
+              <a:t>Page 6 · 07_G2_47-20.png</a:t>
             </a:r>
           </a:p>
         </p:txBody>
       </p:sp>
       <p:pic>
         <p:nvPicPr>
-          <p:cNvPr id="3" name="Picture 2" descr="06_G1_34-21.png"/>
+          <p:cNvPr id="3" name="Picture 2" descr="07_G2_47-20.png"/>
           <p:cNvPicPr>
             <a:picLocks noChangeAspect="1"/>
           </p:cNvPicPr>
@@ -4439,7 +4320,7 @@
                   <a:srgbClr val="1B2A44"/>
                 </a:solidFill>
               </a:rPr>
-              <a:t>• G1 (deck p7): 34 − 21 — child builds with −/+, takes away (ladder: 1st wrong = column line, 2nd = 'इनमें से इतने हटाइए।' + only the needed blocks tappable), the left blocks move right, 13 fills the box, 'इसलिए 34 घटा 21 बराबर 13' in sync.</a:t>
+              <a:t>• G2: options shuffle each time. Wrong 1: 'बची हुई दहाई और इकाई को दोबारा गिनिए।' (the answer table's tens, then ones light); 2: '47 में से 20 घटाने पर, 2 दहाई और 7 इकाई बचती हैं।' (47, 20 light); 3: digits 2 and 7 under the blocks, then the reveal (27 glows + the hand).</a:t>
             </a:r>
           </a:p>
         </p:txBody>
@@ -4490,14 +4371,14 @@
                   <a:srgbClr val="0B3D8C"/>
                 </a:solidFill>
               </a:rPr>
-              <a:t>Page 7 · 07_G2_47-20.png</a:t>
+              <a:t>Page 7 · 08_G3_58-30.png</a:t>
             </a:r>
           </a:p>
         </p:txBody>
       </p:sp>
       <p:pic>
         <p:nvPicPr>
-          <p:cNvPr id="3" name="Picture 2" descr="07_G2_47-20.png"/>
+          <p:cNvPr id="3" name="Picture 2" descr="08_G3_58-30.png"/>
           <p:cNvPicPr>
             <a:picLocks noChangeAspect="1"/>
           </p:cNvPicPr>
@@ -4557,7 +4438,7 @@
                   <a:srgbClr val="1B2A44"/>
                 </a:solidFill>
               </a:rPr>
-              <a:t>• G2 (deck p7b): 47 − 20, options 72 / 27 / 67. Shown: 2nd wrong pick → reveal VO, 27 glows, others locked, hand on it.</a:t>
+              <a:t>• G3 (deck p8): 58 − 30 (deck text said 58 − 38; the mockup, VO and options say 30). Step VO: '0 इकाई मतलब कुछ नहीं घटाएँगे इकाई में से।' then the tens.</a:t>
             </a:r>
           </a:p>
         </p:txBody>
@@ -4608,14 +4489,14 @@
                   <a:srgbClr val="0B3D8C"/>
                 </a:solidFill>
               </a:rPr>
-              <a:t>Page 8 · 08_G3_58-30.png</a:t>
+              <a:t>Page 8 · 09_P1_79-34.png</a:t>
             </a:r>
           </a:p>
         </p:txBody>
       </p:sp>
       <p:pic>
         <p:nvPicPr>
-          <p:cNvPr id="3" name="Picture 2" descr="08_G3_58-30.png"/>
+          <p:cNvPr id="3" name="Picture 2" descr="09_P1_79-34.png"/>
           <p:cNvPicPr>
             <a:picLocks noChangeAspect="1"/>
           </p:cNvPicPr>
@@ -4675,7 +4556,7 @@
                   <a:srgbClr val="1B2A44"/>
                 </a:solidFill>
               </a:rPr>
-              <a:t>• G3 (deck p8): 58 − 30 (deck text said 58 − 38; the mockup, VO and options say 30). Step VO: '0 इकाई मतलब कुछ नहीं घटाएँगे इकाई में से।' then the tens.</a:t>
+              <a:t>• P1 (deck p9): 79 − 34 → number pad. Shown: the right answer after the reveal (keys 4 then 5 lit one by one, the others locked).</a:t>
             </a:r>
           </a:p>
         </p:txBody>

</xml_diff>